<commit_message>
Update test slide titles
</commit_message>
<xml_diff>
--- a/example/template_test.pptx
+++ b/example/template_test.pptx
@@ -8,7 +8,7 @@
     <p:sldId id="256" r:id="rId7"/>
     <p:sldId id="257" r:id="rId8"/>
   </p:sldIdLst>
-  <p:sldSz cx="9144000" cy="5143500" type="screen4x3"/>
+  <p:sldSz cx="9144000" cy="5029200" type="screen4x3"/>
   <p:notesSz cx="6858000" cy="9144000"/>
   <p:defaultTextStyle>
     <a:defPPr>
@@ -3125,7 +3125,7 @@
                   <a:srgbClr val="1B3A5C"/>
                 </a:solidFill>
               </a:rPr>
-              <a:t>Q3 Client Update</a:t>
+              <a:t>Q1'26 Report</a:t>
             </a:r>
           </a:p>
         </p:txBody>
@@ -3184,7 +3184,7 @@
                   <a:srgbClr val="1B3A5C"/>
                 </a:solidFill>
               </a:rPr>
-              <a:t>Key Findings</a:t>
+              <a:t>Key Themes &amp; Overall Takeaways</a:t>
             </a:r>
           </a:p>
         </p:txBody>

</xml_diff>

<commit_message>
Add slide number parameter, add footer formatting with footer line, wordmark, and slide number
</commit_message>
<xml_diff>
--- a/example/template_test.pptx
+++ b/example/template_test.pptx
@@ -3105,8 +3105,8 @@
         </p:nvSpPr>
         <p:spPr>
           <a:xfrm>
-            <a:off x="548640" y="914400"/>
-            <a:ext cx="8046720" cy="914400"/>
+            <a:off x="457200" y="274320"/>
+            <a:ext cx="2743200" cy="274320"/>
           </a:xfrm>
           <a:prstGeom prst="rect">
             <a:avLst/>
@@ -3120,12 +3120,198 @@
           <a:lstStyle/>
           <a:p>
             <a:r>
-              <a:rPr sz="2800" b="1">
+              <a:rPr sz="1200" b="1">
+                <a:solidFill>
+                  <a:srgbClr val="1B3A5C"/>
+                </a:solidFill>
+              </a:rPr>
+              <a:t>DUNCAN &amp; CO.</a:t>
+            </a:r>
+          </a:p>
+        </p:txBody>
+      </p:sp>
+      <p:sp>
+        <p:nvSpPr>
+          <p:cNvPr id="3" name="TextBox 2"/>
+          <p:cNvSpPr txBox="1"/>
+          <p:nvPr/>
+        </p:nvSpPr>
+        <p:spPr>
+          <a:xfrm>
+            <a:off x="457200" y="548640"/>
+            <a:ext cx="7772400" cy="914400"/>
+          </a:xfrm>
+          <a:prstGeom prst="rect">
+            <a:avLst/>
+          </a:prstGeom>
+          <a:noFill/>
+        </p:spPr>
+        <p:txBody>
+          <a:bodyPr wrap="none">
+            <a:spAutoFit/>
+          </a:bodyPr>
+          <a:lstStyle/>
+          <a:p>
+            <a:r>
+              <a:rPr sz="2500" b="1">
                 <a:solidFill>
                   <a:srgbClr val="1B3A5C"/>
                 </a:solidFill>
               </a:rPr>
               <a:t>Q1'26 Report</a:t>
+            </a:r>
+          </a:p>
+        </p:txBody>
+      </p:sp>
+      <p:sp>
+        <p:nvSpPr>
+          <p:cNvPr id="4" name="Rectangle 3"/>
+          <p:cNvSpPr/>
+          <p:nvPr/>
+        </p:nvSpPr>
+        <p:spPr>
+          <a:xfrm>
+            <a:off x="457200" y="960120"/>
+            <a:ext cx="7772400" cy="18288"/>
+          </a:xfrm>
+          <a:prstGeom prst="rect">
+            <a:avLst/>
+          </a:prstGeom>
+          <a:solidFill>
+            <a:srgbClr val="E8792C"/>
+          </a:solidFill>
+          <a:ln>
+            <a:noFill/>
+          </a:ln>
+        </p:spPr>
+        <p:style>
+          <a:lnRef idx="1">
+            <a:schemeClr val="accent1"/>
+          </a:lnRef>
+          <a:fillRef idx="3">
+            <a:schemeClr val="accent1"/>
+          </a:fillRef>
+          <a:effectRef idx="2">
+            <a:schemeClr val="accent1"/>
+          </a:effectRef>
+          <a:fontRef idx="minor">
+            <a:schemeClr val="lt1"/>
+          </a:fontRef>
+        </p:style>
+        <p:txBody>
+          <a:bodyPr rtlCol="0" anchor="ctr"/>
+          <a:lstStyle/>
+          <a:p>
+            <a:pPr algn="ctr"/>
+          </a:p>
+        </p:txBody>
+      </p:sp>
+      <p:sp>
+        <p:nvSpPr>
+          <p:cNvPr id="5" name="Rectangle 4"/>
+          <p:cNvSpPr/>
+          <p:nvPr/>
+        </p:nvSpPr>
+        <p:spPr>
+          <a:xfrm>
+            <a:off x="457200" y="4846320"/>
+            <a:ext cx="7772400" cy="18288"/>
+          </a:xfrm>
+          <a:prstGeom prst="rect">
+            <a:avLst/>
+          </a:prstGeom>
+          <a:solidFill>
+            <a:srgbClr val="808080"/>
+          </a:solidFill>
+          <a:ln>
+            <a:noFill/>
+          </a:ln>
+        </p:spPr>
+        <p:style>
+          <a:lnRef idx="1">
+            <a:schemeClr val="accent1"/>
+          </a:lnRef>
+          <a:fillRef idx="3">
+            <a:schemeClr val="accent1"/>
+          </a:fillRef>
+          <a:effectRef idx="2">
+            <a:schemeClr val="accent1"/>
+          </a:effectRef>
+          <a:fontRef idx="minor">
+            <a:schemeClr val="lt1"/>
+          </a:fontRef>
+        </p:style>
+        <p:txBody>
+          <a:bodyPr rtlCol="0" anchor="ctr"/>
+          <a:lstStyle/>
+          <a:p>
+            <a:pPr algn="ctr"/>
+          </a:p>
+        </p:txBody>
+      </p:sp>
+      <p:sp>
+        <p:nvSpPr>
+          <p:cNvPr id="6" name="TextBox 5"/>
+          <p:cNvSpPr txBox="1"/>
+          <p:nvPr/>
+        </p:nvSpPr>
+        <p:spPr>
+          <a:xfrm>
+            <a:off x="457200" y="4663440"/>
+            <a:ext cx="3657600" cy="274320"/>
+          </a:xfrm>
+          <a:prstGeom prst="rect">
+            <a:avLst/>
+          </a:prstGeom>
+          <a:noFill/>
+        </p:spPr>
+        <p:txBody>
+          <a:bodyPr wrap="none">
+            <a:spAutoFit/>
+          </a:bodyPr>
+          <a:lstStyle/>
+          <a:p>
+            <a:r>
+              <a:rPr sz="900">
+                <a:solidFill>
+                  <a:srgbClr val="808080"/>
+                </a:solidFill>
+              </a:rPr>
+              <a:t>Duncan &amp; Co.</a:t>
+            </a:r>
+          </a:p>
+        </p:txBody>
+      </p:sp>
+      <p:sp>
+        <p:nvSpPr>
+          <p:cNvPr id="7" name="TextBox 6"/>
+          <p:cNvSpPr txBox="1"/>
+          <p:nvPr/>
+        </p:nvSpPr>
+        <p:spPr>
+          <a:xfrm>
+            <a:off x="7772400" y="4663440"/>
+            <a:ext cx="457200" cy="182880"/>
+          </a:xfrm>
+          <a:prstGeom prst="rect">
+            <a:avLst/>
+          </a:prstGeom>
+          <a:noFill/>
+        </p:spPr>
+        <p:txBody>
+          <a:bodyPr wrap="none">
+            <a:spAutoFit/>
+          </a:bodyPr>
+          <a:lstStyle/>
+          <a:p>
+            <a:pPr algn="r"/>
+            <a:r>
+              <a:rPr sz="900">
+                <a:solidFill>
+                  <a:srgbClr val="808080"/>
+                </a:solidFill>
+              </a:rPr>
+              <a:t>1</a:t>
             </a:r>
           </a:p>
         </p:txBody>
@@ -3164,8 +3350,8 @@
         </p:nvSpPr>
         <p:spPr>
           <a:xfrm>
-            <a:off x="548640" y="914400"/>
-            <a:ext cx="8046720" cy="914400"/>
+            <a:off x="457200" y="274320"/>
+            <a:ext cx="2743200" cy="274320"/>
           </a:xfrm>
           <a:prstGeom prst="rect">
             <a:avLst/>
@@ -3179,12 +3365,198 @@
           <a:lstStyle/>
           <a:p>
             <a:r>
-              <a:rPr sz="2800" b="1">
+              <a:rPr sz="1200" b="1">
+                <a:solidFill>
+                  <a:srgbClr val="1B3A5C"/>
+                </a:solidFill>
+              </a:rPr>
+              <a:t>DUNCAN &amp; CO.</a:t>
+            </a:r>
+          </a:p>
+        </p:txBody>
+      </p:sp>
+      <p:sp>
+        <p:nvSpPr>
+          <p:cNvPr id="3" name="TextBox 2"/>
+          <p:cNvSpPr txBox="1"/>
+          <p:nvPr/>
+        </p:nvSpPr>
+        <p:spPr>
+          <a:xfrm>
+            <a:off x="457200" y="548640"/>
+            <a:ext cx="7772400" cy="914400"/>
+          </a:xfrm>
+          <a:prstGeom prst="rect">
+            <a:avLst/>
+          </a:prstGeom>
+          <a:noFill/>
+        </p:spPr>
+        <p:txBody>
+          <a:bodyPr wrap="none">
+            <a:spAutoFit/>
+          </a:bodyPr>
+          <a:lstStyle/>
+          <a:p>
+            <a:r>
+              <a:rPr sz="2500" b="1">
                 <a:solidFill>
                   <a:srgbClr val="1B3A5C"/>
                 </a:solidFill>
               </a:rPr>
               <a:t>Key Themes &amp; Overall Takeaways</a:t>
+            </a:r>
+          </a:p>
+        </p:txBody>
+      </p:sp>
+      <p:sp>
+        <p:nvSpPr>
+          <p:cNvPr id="4" name="Rectangle 3"/>
+          <p:cNvSpPr/>
+          <p:nvPr/>
+        </p:nvSpPr>
+        <p:spPr>
+          <a:xfrm>
+            <a:off x="457200" y="960120"/>
+            <a:ext cx="7772400" cy="18288"/>
+          </a:xfrm>
+          <a:prstGeom prst="rect">
+            <a:avLst/>
+          </a:prstGeom>
+          <a:solidFill>
+            <a:srgbClr val="E8792C"/>
+          </a:solidFill>
+          <a:ln>
+            <a:noFill/>
+          </a:ln>
+        </p:spPr>
+        <p:style>
+          <a:lnRef idx="1">
+            <a:schemeClr val="accent1"/>
+          </a:lnRef>
+          <a:fillRef idx="3">
+            <a:schemeClr val="accent1"/>
+          </a:fillRef>
+          <a:effectRef idx="2">
+            <a:schemeClr val="accent1"/>
+          </a:effectRef>
+          <a:fontRef idx="minor">
+            <a:schemeClr val="lt1"/>
+          </a:fontRef>
+        </p:style>
+        <p:txBody>
+          <a:bodyPr rtlCol="0" anchor="ctr"/>
+          <a:lstStyle/>
+          <a:p>
+            <a:pPr algn="ctr"/>
+          </a:p>
+        </p:txBody>
+      </p:sp>
+      <p:sp>
+        <p:nvSpPr>
+          <p:cNvPr id="5" name="Rectangle 4"/>
+          <p:cNvSpPr/>
+          <p:nvPr/>
+        </p:nvSpPr>
+        <p:spPr>
+          <a:xfrm>
+            <a:off x="457200" y="4846320"/>
+            <a:ext cx="7772400" cy="18288"/>
+          </a:xfrm>
+          <a:prstGeom prst="rect">
+            <a:avLst/>
+          </a:prstGeom>
+          <a:solidFill>
+            <a:srgbClr val="808080"/>
+          </a:solidFill>
+          <a:ln>
+            <a:noFill/>
+          </a:ln>
+        </p:spPr>
+        <p:style>
+          <a:lnRef idx="1">
+            <a:schemeClr val="accent1"/>
+          </a:lnRef>
+          <a:fillRef idx="3">
+            <a:schemeClr val="accent1"/>
+          </a:fillRef>
+          <a:effectRef idx="2">
+            <a:schemeClr val="accent1"/>
+          </a:effectRef>
+          <a:fontRef idx="minor">
+            <a:schemeClr val="lt1"/>
+          </a:fontRef>
+        </p:style>
+        <p:txBody>
+          <a:bodyPr rtlCol="0" anchor="ctr"/>
+          <a:lstStyle/>
+          <a:p>
+            <a:pPr algn="ctr"/>
+          </a:p>
+        </p:txBody>
+      </p:sp>
+      <p:sp>
+        <p:nvSpPr>
+          <p:cNvPr id="6" name="TextBox 5"/>
+          <p:cNvSpPr txBox="1"/>
+          <p:nvPr/>
+        </p:nvSpPr>
+        <p:spPr>
+          <a:xfrm>
+            <a:off x="457200" y="4663440"/>
+            <a:ext cx="3657600" cy="274320"/>
+          </a:xfrm>
+          <a:prstGeom prst="rect">
+            <a:avLst/>
+          </a:prstGeom>
+          <a:noFill/>
+        </p:spPr>
+        <p:txBody>
+          <a:bodyPr wrap="none">
+            <a:spAutoFit/>
+          </a:bodyPr>
+          <a:lstStyle/>
+          <a:p>
+            <a:r>
+              <a:rPr sz="900">
+                <a:solidFill>
+                  <a:srgbClr val="808080"/>
+                </a:solidFill>
+              </a:rPr>
+              <a:t>Duncan &amp; Co.</a:t>
+            </a:r>
+          </a:p>
+        </p:txBody>
+      </p:sp>
+      <p:sp>
+        <p:nvSpPr>
+          <p:cNvPr id="7" name="TextBox 6"/>
+          <p:cNvSpPr txBox="1"/>
+          <p:nvPr/>
+        </p:nvSpPr>
+        <p:spPr>
+          <a:xfrm>
+            <a:off x="7772400" y="4663440"/>
+            <a:ext cx="457200" cy="182880"/>
+          </a:xfrm>
+          <a:prstGeom prst="rect">
+            <a:avLst/>
+          </a:prstGeom>
+          <a:noFill/>
+        </p:spPr>
+        <p:txBody>
+          <a:bodyPr wrap="none">
+            <a:spAutoFit/>
+          </a:bodyPr>
+          <a:lstStyle/>
+          <a:p>
+            <a:pPr algn="r"/>
+            <a:r>
+              <a:rPr sz="900">
+                <a:solidFill>
+                  <a:srgbClr val="808080"/>
+                </a:solidFill>
+              </a:rPr>
+              <a:t>2</a:t>
             </a:r>
           </a:p>
         </p:txBody>

</xml_diff>

<commit_message>
Add logo asset, insert to slides, refine spacing
</commit_message>
<xml_diff>
--- a/example/template_test.pptx
+++ b/example/template_test.pptx
@@ -3105,7 +3105,7 @@
         </p:nvSpPr>
         <p:spPr>
           <a:xfrm>
-            <a:off x="457200" y="274320"/>
+            <a:off x="914400" y="137160"/>
             <a:ext cx="2743200" cy="274320"/>
           </a:xfrm>
           <a:prstGeom prst="rect">
@@ -3138,7 +3138,7 @@
         </p:nvSpPr>
         <p:spPr>
           <a:xfrm>
-            <a:off x="457200" y="548640"/>
+            <a:off x="914400" y="365760"/>
             <a:ext cx="7772400" cy="914400"/>
           </a:xfrm>
           <a:prstGeom prst="rect">
@@ -3171,8 +3171,8 @@
         </p:nvSpPr>
         <p:spPr>
           <a:xfrm>
-            <a:off x="457200" y="960120"/>
-            <a:ext cx="7772400" cy="18288"/>
+            <a:off x="457200" y="914400"/>
+            <a:ext cx="8686800" cy="18288"/>
           </a:xfrm>
           <a:prstGeom prst="rect">
             <a:avLst/>
@@ -3215,7 +3215,7 @@
         <p:spPr>
           <a:xfrm>
             <a:off x="457200" y="4846320"/>
-            <a:ext cx="7772400" cy="18288"/>
+            <a:ext cx="8686800" cy="18288"/>
           </a:xfrm>
           <a:prstGeom prst="rect">
             <a:avLst/>
@@ -3316,6 +3316,30 @@
           </a:p>
         </p:txBody>
       </p:sp>
+      <p:pic>
+        <p:nvPicPr>
+          <p:cNvPr id="8" name="Picture 7" descr="logo.png"/>
+          <p:cNvPicPr>
+            <a:picLocks noChangeAspect="1"/>
+          </p:cNvPicPr>
+          <p:nvPr/>
+        </p:nvPicPr>
+        <p:blipFill>
+          <a:blip r:embed="rId2"/>
+          <a:stretch>
+            <a:fillRect/>
+          </a:stretch>
+        </p:blipFill>
+        <p:spPr>
+          <a:xfrm>
+            <a:off x="228600" y="137160"/>
+            <a:ext cx="685180" cy="640080"/>
+          </a:xfrm>
+          <a:prstGeom prst="rect">
+            <a:avLst/>
+          </a:prstGeom>
+        </p:spPr>
+      </p:pic>
     </p:spTree>
   </p:cSld>
   <p:clrMapOvr>
@@ -3350,7 +3374,7 @@
         </p:nvSpPr>
         <p:spPr>
           <a:xfrm>
-            <a:off x="457200" y="274320"/>
+            <a:off x="914400" y="137160"/>
             <a:ext cx="2743200" cy="274320"/>
           </a:xfrm>
           <a:prstGeom prst="rect">
@@ -3383,7 +3407,7 @@
         </p:nvSpPr>
         <p:spPr>
           <a:xfrm>
-            <a:off x="457200" y="548640"/>
+            <a:off x="914400" y="365760"/>
             <a:ext cx="7772400" cy="914400"/>
           </a:xfrm>
           <a:prstGeom prst="rect">
@@ -3416,8 +3440,8 @@
         </p:nvSpPr>
         <p:spPr>
           <a:xfrm>
-            <a:off x="457200" y="960120"/>
-            <a:ext cx="7772400" cy="18288"/>
+            <a:off x="457200" y="914400"/>
+            <a:ext cx="8686800" cy="18288"/>
           </a:xfrm>
           <a:prstGeom prst="rect">
             <a:avLst/>
@@ -3460,7 +3484,7 @@
         <p:spPr>
           <a:xfrm>
             <a:off x="457200" y="4846320"/>
-            <a:ext cx="7772400" cy="18288"/>
+            <a:ext cx="8686800" cy="18288"/>
           </a:xfrm>
           <a:prstGeom prst="rect">
             <a:avLst/>
@@ -3561,6 +3585,30 @@
           </a:p>
         </p:txBody>
       </p:sp>
+      <p:pic>
+        <p:nvPicPr>
+          <p:cNvPr id="8" name="Picture 7" descr="logo.png"/>
+          <p:cNvPicPr>
+            <a:picLocks noChangeAspect="1"/>
+          </p:cNvPicPr>
+          <p:nvPr/>
+        </p:nvPicPr>
+        <p:blipFill>
+          <a:blip r:embed="rId2"/>
+          <a:stretch>
+            <a:fillRect/>
+          </a:stretch>
+        </p:blipFill>
+        <p:spPr>
+          <a:xfrm>
+            <a:off x="228600" y="137160"/>
+            <a:ext cx="685180" cy="640080"/>
+          </a:xfrm>
+          <a:prstGeom prst="rect">
+            <a:avLst/>
+          </a:prstGeom>
+        </p:spPr>
+      </p:pic>
     </p:spTree>
   </p:cSld>
   <p:clrMapOvr>

</xml_diff>

<commit_message>
Add dynamic sizing for title text, wrap text for title, and adjust header & footer lines
</commit_message>
<xml_diff>
--- a/example/template_test.pptx
+++ b/example/template_test.pptx
@@ -7,6 +7,9 @@
   <p:sldIdLst>
     <p:sldId id="256" r:id="rId7"/>
     <p:sldId id="257" r:id="rId8"/>
+    <p:sldId id="258" r:id="rId9"/>
+    <p:sldId id="259" r:id="rId10"/>
+    <p:sldId id="260" r:id="rId11"/>
   </p:sldIdLst>
   <p:sldSz cx="9144000" cy="5029200" type="screen4x3"/>
   <p:notesSz cx="6858000" cy="9144000"/>
@@ -3147,7 +3150,7 @@
           <a:noFill/>
         </p:spPr>
         <p:txBody>
-          <a:bodyPr wrap="none">
+          <a:bodyPr wrap="square">
             <a:spAutoFit/>
           </a:bodyPr>
           <a:lstStyle/>
@@ -3172,7 +3175,7 @@
         <p:spPr>
           <a:xfrm>
             <a:off x="457200" y="914400"/>
-            <a:ext cx="8686800" cy="18288"/>
+            <a:ext cx="7772400" cy="18288"/>
           </a:xfrm>
           <a:prstGeom prst="rect">
             <a:avLst/>
@@ -3215,7 +3218,7 @@
         <p:spPr>
           <a:xfrm>
             <a:off x="457200" y="4846320"/>
-            <a:ext cx="8686800" cy="18288"/>
+            <a:ext cx="7772400" cy="18288"/>
           </a:xfrm>
           <a:prstGeom prst="rect">
             <a:avLst/>
@@ -3416,7 +3419,7 @@
           <a:noFill/>
         </p:spPr>
         <p:txBody>
-          <a:bodyPr wrap="none">
+          <a:bodyPr wrap="square">
             <a:spAutoFit/>
           </a:bodyPr>
           <a:lstStyle/>
@@ -3441,7 +3444,7 @@
         <p:spPr>
           <a:xfrm>
             <a:off x="457200" y="914400"/>
-            <a:ext cx="8686800" cy="18288"/>
+            <a:ext cx="7772400" cy="18288"/>
           </a:xfrm>
           <a:prstGeom prst="rect">
             <a:avLst/>
@@ -3484,7 +3487,7 @@
         <p:spPr>
           <a:xfrm>
             <a:off x="457200" y="4846320"/>
-            <a:ext cx="8686800" cy="18288"/>
+            <a:ext cx="7772400" cy="18288"/>
           </a:xfrm>
           <a:prstGeom prst="rect">
             <a:avLst/>
@@ -3581,6 +3584,813 @@
                 </a:solidFill>
               </a:rPr>
               <a:t>2</a:t>
+            </a:r>
+          </a:p>
+        </p:txBody>
+      </p:sp>
+      <p:pic>
+        <p:nvPicPr>
+          <p:cNvPr id="8" name="Picture 7" descr="logo.png"/>
+          <p:cNvPicPr>
+            <a:picLocks noChangeAspect="1"/>
+          </p:cNvPicPr>
+          <p:nvPr/>
+        </p:nvPicPr>
+        <p:blipFill>
+          <a:blip r:embed="rId2"/>
+          <a:stretch>
+            <a:fillRect/>
+          </a:stretch>
+        </p:blipFill>
+        <p:spPr>
+          <a:xfrm>
+            <a:off x="228600" y="137160"/>
+            <a:ext cx="685180" cy="640080"/>
+          </a:xfrm>
+          <a:prstGeom prst="rect">
+            <a:avLst/>
+          </a:prstGeom>
+        </p:spPr>
+      </p:pic>
+    </p:spTree>
+  </p:cSld>
+  <p:clrMapOvr>
+    <a:masterClrMapping/>
+  </p:clrMapOvr>
+</p:sld>
+</file>
+
+<file path=ppt/slides/slide3.xml><?xml version="1.0" encoding="utf-8"?>
+<p:sld xmlns:a="http://schemas.openxmlformats.org/drawingml/2006/main" xmlns:p="http://schemas.openxmlformats.org/presentationml/2006/main" xmlns:r="http://schemas.openxmlformats.org/officeDocument/2006/relationships">
+  <p:cSld>
+    <p:bg>
+      <p:bgPr>
+        <a:solidFill>
+          <a:srgbClr val="FAFAFA"/>
+        </a:solidFill>
+        <a:effectLst/>
+      </p:bgPr>
+    </p:bg>
+    <p:spTree>
+      <p:nvGrpSpPr>
+        <p:cNvPr id="1" name=""/>
+        <p:cNvGrpSpPr/>
+        <p:nvPr/>
+      </p:nvGrpSpPr>
+      <p:grpSpPr/>
+      <p:sp>
+        <p:nvSpPr>
+          <p:cNvPr id="2" name="TextBox 1"/>
+          <p:cNvSpPr txBox="1"/>
+          <p:nvPr/>
+        </p:nvSpPr>
+        <p:spPr>
+          <a:xfrm>
+            <a:off x="914400" y="137160"/>
+            <a:ext cx="2743200" cy="274320"/>
+          </a:xfrm>
+          <a:prstGeom prst="rect">
+            <a:avLst/>
+          </a:prstGeom>
+          <a:noFill/>
+        </p:spPr>
+        <p:txBody>
+          <a:bodyPr wrap="none">
+            <a:spAutoFit/>
+          </a:bodyPr>
+          <a:lstStyle/>
+          <a:p>
+            <a:r>
+              <a:rPr sz="1200" b="1">
+                <a:solidFill>
+                  <a:srgbClr val="1B3A5C"/>
+                </a:solidFill>
+              </a:rPr>
+              <a:t>DUNCAN &amp; CO.</a:t>
+            </a:r>
+          </a:p>
+        </p:txBody>
+      </p:sp>
+      <p:sp>
+        <p:nvSpPr>
+          <p:cNvPr id="3" name="TextBox 2"/>
+          <p:cNvSpPr txBox="1"/>
+          <p:nvPr/>
+        </p:nvSpPr>
+        <p:spPr>
+          <a:xfrm>
+            <a:off x="914400" y="365760"/>
+            <a:ext cx="7772400" cy="914400"/>
+          </a:xfrm>
+          <a:prstGeom prst="rect">
+            <a:avLst/>
+          </a:prstGeom>
+          <a:noFill/>
+        </p:spPr>
+        <p:txBody>
+          <a:bodyPr wrap="square">
+            <a:spAutoFit/>
+          </a:bodyPr>
+          <a:lstStyle/>
+          <a:p>
+            <a:r>
+              <a:rPr sz="2500" b="1">
+                <a:solidFill>
+                  <a:srgbClr val="1B3A5C"/>
+                </a:solidFill>
+              </a:rPr>
+              <a:t>Risk</a:t>
+            </a:r>
+          </a:p>
+        </p:txBody>
+      </p:sp>
+      <p:sp>
+        <p:nvSpPr>
+          <p:cNvPr id="4" name="Rectangle 3"/>
+          <p:cNvSpPr/>
+          <p:nvPr/>
+        </p:nvSpPr>
+        <p:spPr>
+          <a:xfrm>
+            <a:off x="457200" y="914400"/>
+            <a:ext cx="7772400" cy="18288"/>
+          </a:xfrm>
+          <a:prstGeom prst="rect">
+            <a:avLst/>
+          </a:prstGeom>
+          <a:solidFill>
+            <a:srgbClr val="E8792C"/>
+          </a:solidFill>
+          <a:ln>
+            <a:noFill/>
+          </a:ln>
+        </p:spPr>
+        <p:style>
+          <a:lnRef idx="1">
+            <a:schemeClr val="accent1"/>
+          </a:lnRef>
+          <a:fillRef idx="3">
+            <a:schemeClr val="accent1"/>
+          </a:fillRef>
+          <a:effectRef idx="2">
+            <a:schemeClr val="accent1"/>
+          </a:effectRef>
+          <a:fontRef idx="minor">
+            <a:schemeClr val="lt1"/>
+          </a:fontRef>
+        </p:style>
+        <p:txBody>
+          <a:bodyPr rtlCol="0" anchor="ctr"/>
+          <a:lstStyle/>
+          <a:p>
+            <a:pPr algn="ctr"/>
+          </a:p>
+        </p:txBody>
+      </p:sp>
+      <p:sp>
+        <p:nvSpPr>
+          <p:cNvPr id="5" name="Rectangle 4"/>
+          <p:cNvSpPr/>
+          <p:nvPr/>
+        </p:nvSpPr>
+        <p:spPr>
+          <a:xfrm>
+            <a:off x="457200" y="4846320"/>
+            <a:ext cx="7772400" cy="18288"/>
+          </a:xfrm>
+          <a:prstGeom prst="rect">
+            <a:avLst/>
+          </a:prstGeom>
+          <a:solidFill>
+            <a:srgbClr val="808080"/>
+          </a:solidFill>
+          <a:ln>
+            <a:noFill/>
+          </a:ln>
+        </p:spPr>
+        <p:style>
+          <a:lnRef idx="1">
+            <a:schemeClr val="accent1"/>
+          </a:lnRef>
+          <a:fillRef idx="3">
+            <a:schemeClr val="accent1"/>
+          </a:fillRef>
+          <a:effectRef idx="2">
+            <a:schemeClr val="accent1"/>
+          </a:effectRef>
+          <a:fontRef idx="minor">
+            <a:schemeClr val="lt1"/>
+          </a:fontRef>
+        </p:style>
+        <p:txBody>
+          <a:bodyPr rtlCol="0" anchor="ctr"/>
+          <a:lstStyle/>
+          <a:p>
+            <a:pPr algn="ctr"/>
+          </a:p>
+        </p:txBody>
+      </p:sp>
+      <p:sp>
+        <p:nvSpPr>
+          <p:cNvPr id="6" name="TextBox 5"/>
+          <p:cNvSpPr txBox="1"/>
+          <p:nvPr/>
+        </p:nvSpPr>
+        <p:spPr>
+          <a:xfrm>
+            <a:off x="457200" y="4663440"/>
+            <a:ext cx="3657600" cy="274320"/>
+          </a:xfrm>
+          <a:prstGeom prst="rect">
+            <a:avLst/>
+          </a:prstGeom>
+          <a:noFill/>
+        </p:spPr>
+        <p:txBody>
+          <a:bodyPr wrap="none">
+            <a:spAutoFit/>
+          </a:bodyPr>
+          <a:lstStyle/>
+          <a:p>
+            <a:r>
+              <a:rPr sz="900">
+                <a:solidFill>
+                  <a:srgbClr val="808080"/>
+                </a:solidFill>
+              </a:rPr>
+              <a:t>Duncan &amp; Co.</a:t>
+            </a:r>
+          </a:p>
+        </p:txBody>
+      </p:sp>
+      <p:sp>
+        <p:nvSpPr>
+          <p:cNvPr id="7" name="TextBox 6"/>
+          <p:cNvSpPr txBox="1"/>
+          <p:nvPr/>
+        </p:nvSpPr>
+        <p:spPr>
+          <a:xfrm>
+            <a:off x="7772400" y="4663440"/>
+            <a:ext cx="457200" cy="182880"/>
+          </a:xfrm>
+          <a:prstGeom prst="rect">
+            <a:avLst/>
+          </a:prstGeom>
+          <a:noFill/>
+        </p:spPr>
+        <p:txBody>
+          <a:bodyPr wrap="none">
+            <a:spAutoFit/>
+          </a:bodyPr>
+          <a:lstStyle/>
+          <a:p>
+            <a:pPr algn="r"/>
+            <a:r>
+              <a:rPr sz="900">
+                <a:solidFill>
+                  <a:srgbClr val="808080"/>
+                </a:solidFill>
+              </a:rPr>
+              <a:t>3</a:t>
+            </a:r>
+          </a:p>
+        </p:txBody>
+      </p:sp>
+      <p:pic>
+        <p:nvPicPr>
+          <p:cNvPr id="8" name="Picture 7" descr="logo.png"/>
+          <p:cNvPicPr>
+            <a:picLocks noChangeAspect="1"/>
+          </p:cNvPicPr>
+          <p:nvPr/>
+        </p:nvPicPr>
+        <p:blipFill>
+          <a:blip r:embed="rId2"/>
+          <a:stretch>
+            <a:fillRect/>
+          </a:stretch>
+        </p:blipFill>
+        <p:spPr>
+          <a:xfrm>
+            <a:off x="228600" y="137160"/>
+            <a:ext cx="685180" cy="640080"/>
+          </a:xfrm>
+          <a:prstGeom prst="rect">
+            <a:avLst/>
+          </a:prstGeom>
+        </p:spPr>
+      </p:pic>
+    </p:spTree>
+  </p:cSld>
+  <p:clrMapOvr>
+    <a:masterClrMapping/>
+  </p:clrMapOvr>
+</p:sld>
+</file>
+
+<file path=ppt/slides/slide4.xml><?xml version="1.0" encoding="utf-8"?>
+<p:sld xmlns:a="http://schemas.openxmlformats.org/drawingml/2006/main" xmlns:p="http://schemas.openxmlformats.org/presentationml/2006/main" xmlns:r="http://schemas.openxmlformats.org/officeDocument/2006/relationships">
+  <p:cSld>
+    <p:bg>
+      <p:bgPr>
+        <a:solidFill>
+          <a:srgbClr val="FAFAFA"/>
+        </a:solidFill>
+        <a:effectLst/>
+      </p:bgPr>
+    </p:bg>
+    <p:spTree>
+      <p:nvGrpSpPr>
+        <p:cNvPr id="1" name=""/>
+        <p:cNvGrpSpPr/>
+        <p:nvPr/>
+      </p:nvGrpSpPr>
+      <p:grpSpPr/>
+      <p:sp>
+        <p:nvSpPr>
+          <p:cNvPr id="2" name="TextBox 1"/>
+          <p:cNvSpPr txBox="1"/>
+          <p:nvPr/>
+        </p:nvSpPr>
+        <p:spPr>
+          <a:xfrm>
+            <a:off x="914400" y="137160"/>
+            <a:ext cx="2743200" cy="274320"/>
+          </a:xfrm>
+          <a:prstGeom prst="rect">
+            <a:avLst/>
+          </a:prstGeom>
+          <a:noFill/>
+        </p:spPr>
+        <p:txBody>
+          <a:bodyPr wrap="none">
+            <a:spAutoFit/>
+          </a:bodyPr>
+          <a:lstStyle/>
+          <a:p>
+            <a:r>
+              <a:rPr sz="1200" b="1">
+                <a:solidFill>
+                  <a:srgbClr val="1B3A5C"/>
+                </a:solidFill>
+              </a:rPr>
+              <a:t>DUNCAN &amp; CO.</a:t>
+            </a:r>
+          </a:p>
+        </p:txBody>
+      </p:sp>
+      <p:sp>
+        <p:nvSpPr>
+          <p:cNvPr id="3" name="TextBox 2"/>
+          <p:cNvSpPr txBox="1"/>
+          <p:nvPr/>
+        </p:nvSpPr>
+        <p:spPr>
+          <a:xfrm>
+            <a:off x="914400" y="365760"/>
+            <a:ext cx="7772400" cy="914400"/>
+          </a:xfrm>
+          <a:prstGeom prst="rect">
+            <a:avLst/>
+          </a:prstGeom>
+          <a:noFill/>
+        </p:spPr>
+        <p:txBody>
+          <a:bodyPr wrap="square">
+            <a:spAutoFit/>
+          </a:bodyPr>
+          <a:lstStyle/>
+          <a:p>
+            <a:r>
+              <a:rPr sz="2000" b="1">
+                <a:solidFill>
+                  <a:srgbClr val="1B3A5C"/>
+                </a:solidFill>
+              </a:rPr>
+              <a:t>Customer Pipeline and Revenue Guidance for the Upcoming Fiscal Year</a:t>
+            </a:r>
+          </a:p>
+        </p:txBody>
+      </p:sp>
+      <p:sp>
+        <p:nvSpPr>
+          <p:cNvPr id="4" name="Rectangle 3"/>
+          <p:cNvSpPr/>
+          <p:nvPr/>
+        </p:nvSpPr>
+        <p:spPr>
+          <a:xfrm>
+            <a:off x="457200" y="914400"/>
+            <a:ext cx="7772400" cy="18288"/>
+          </a:xfrm>
+          <a:prstGeom prst="rect">
+            <a:avLst/>
+          </a:prstGeom>
+          <a:solidFill>
+            <a:srgbClr val="E8792C"/>
+          </a:solidFill>
+          <a:ln>
+            <a:noFill/>
+          </a:ln>
+        </p:spPr>
+        <p:style>
+          <a:lnRef idx="1">
+            <a:schemeClr val="accent1"/>
+          </a:lnRef>
+          <a:fillRef idx="3">
+            <a:schemeClr val="accent1"/>
+          </a:fillRef>
+          <a:effectRef idx="2">
+            <a:schemeClr val="accent1"/>
+          </a:effectRef>
+          <a:fontRef idx="minor">
+            <a:schemeClr val="lt1"/>
+          </a:fontRef>
+        </p:style>
+        <p:txBody>
+          <a:bodyPr rtlCol="0" anchor="ctr"/>
+          <a:lstStyle/>
+          <a:p>
+            <a:pPr algn="ctr"/>
+          </a:p>
+        </p:txBody>
+      </p:sp>
+      <p:sp>
+        <p:nvSpPr>
+          <p:cNvPr id="5" name="Rectangle 4"/>
+          <p:cNvSpPr/>
+          <p:nvPr/>
+        </p:nvSpPr>
+        <p:spPr>
+          <a:xfrm>
+            <a:off x="457200" y="4846320"/>
+            <a:ext cx="7772400" cy="18288"/>
+          </a:xfrm>
+          <a:prstGeom prst="rect">
+            <a:avLst/>
+          </a:prstGeom>
+          <a:solidFill>
+            <a:srgbClr val="808080"/>
+          </a:solidFill>
+          <a:ln>
+            <a:noFill/>
+          </a:ln>
+        </p:spPr>
+        <p:style>
+          <a:lnRef idx="1">
+            <a:schemeClr val="accent1"/>
+          </a:lnRef>
+          <a:fillRef idx="3">
+            <a:schemeClr val="accent1"/>
+          </a:fillRef>
+          <a:effectRef idx="2">
+            <a:schemeClr val="accent1"/>
+          </a:effectRef>
+          <a:fontRef idx="minor">
+            <a:schemeClr val="lt1"/>
+          </a:fontRef>
+        </p:style>
+        <p:txBody>
+          <a:bodyPr rtlCol="0" anchor="ctr"/>
+          <a:lstStyle/>
+          <a:p>
+            <a:pPr algn="ctr"/>
+          </a:p>
+        </p:txBody>
+      </p:sp>
+      <p:sp>
+        <p:nvSpPr>
+          <p:cNvPr id="6" name="TextBox 5"/>
+          <p:cNvSpPr txBox="1"/>
+          <p:nvPr/>
+        </p:nvSpPr>
+        <p:spPr>
+          <a:xfrm>
+            <a:off x="457200" y="4663440"/>
+            <a:ext cx="3657600" cy="274320"/>
+          </a:xfrm>
+          <a:prstGeom prst="rect">
+            <a:avLst/>
+          </a:prstGeom>
+          <a:noFill/>
+        </p:spPr>
+        <p:txBody>
+          <a:bodyPr wrap="none">
+            <a:spAutoFit/>
+          </a:bodyPr>
+          <a:lstStyle/>
+          <a:p>
+            <a:r>
+              <a:rPr sz="900">
+                <a:solidFill>
+                  <a:srgbClr val="808080"/>
+                </a:solidFill>
+              </a:rPr>
+              <a:t>Duncan &amp; Co.</a:t>
+            </a:r>
+          </a:p>
+        </p:txBody>
+      </p:sp>
+      <p:sp>
+        <p:nvSpPr>
+          <p:cNvPr id="7" name="TextBox 6"/>
+          <p:cNvSpPr txBox="1"/>
+          <p:nvPr/>
+        </p:nvSpPr>
+        <p:spPr>
+          <a:xfrm>
+            <a:off x="7772400" y="4663440"/>
+            <a:ext cx="457200" cy="182880"/>
+          </a:xfrm>
+          <a:prstGeom prst="rect">
+            <a:avLst/>
+          </a:prstGeom>
+          <a:noFill/>
+        </p:spPr>
+        <p:txBody>
+          <a:bodyPr wrap="none">
+            <a:spAutoFit/>
+          </a:bodyPr>
+          <a:lstStyle/>
+          <a:p>
+            <a:pPr algn="r"/>
+            <a:r>
+              <a:rPr sz="900">
+                <a:solidFill>
+                  <a:srgbClr val="808080"/>
+                </a:solidFill>
+              </a:rPr>
+              <a:t>4</a:t>
+            </a:r>
+          </a:p>
+        </p:txBody>
+      </p:sp>
+      <p:pic>
+        <p:nvPicPr>
+          <p:cNvPr id="8" name="Picture 7" descr="logo.png"/>
+          <p:cNvPicPr>
+            <a:picLocks noChangeAspect="1"/>
+          </p:cNvPicPr>
+          <p:nvPr/>
+        </p:nvPicPr>
+        <p:blipFill>
+          <a:blip r:embed="rId2"/>
+          <a:stretch>
+            <a:fillRect/>
+          </a:stretch>
+        </p:blipFill>
+        <p:spPr>
+          <a:xfrm>
+            <a:off x="228600" y="137160"/>
+            <a:ext cx="685180" cy="640080"/>
+          </a:xfrm>
+          <a:prstGeom prst="rect">
+            <a:avLst/>
+          </a:prstGeom>
+        </p:spPr>
+      </p:pic>
+    </p:spTree>
+  </p:cSld>
+  <p:clrMapOvr>
+    <a:masterClrMapping/>
+  </p:clrMapOvr>
+</p:sld>
+</file>
+
+<file path=ppt/slides/slide5.xml><?xml version="1.0" encoding="utf-8"?>
+<p:sld xmlns:a="http://schemas.openxmlformats.org/drawingml/2006/main" xmlns:p="http://schemas.openxmlformats.org/presentationml/2006/main" xmlns:r="http://schemas.openxmlformats.org/officeDocument/2006/relationships">
+  <p:cSld>
+    <p:bg>
+      <p:bgPr>
+        <a:solidFill>
+          <a:srgbClr val="FAFAFA"/>
+        </a:solidFill>
+        <a:effectLst/>
+      </p:bgPr>
+    </p:bg>
+    <p:spTree>
+      <p:nvGrpSpPr>
+        <p:cNvPr id="1" name=""/>
+        <p:cNvGrpSpPr/>
+        <p:nvPr/>
+      </p:nvGrpSpPr>
+      <p:grpSpPr/>
+      <p:sp>
+        <p:nvSpPr>
+          <p:cNvPr id="2" name="TextBox 1"/>
+          <p:cNvSpPr txBox="1"/>
+          <p:nvPr/>
+        </p:nvSpPr>
+        <p:spPr>
+          <a:xfrm>
+            <a:off x="914400" y="137160"/>
+            <a:ext cx="2743200" cy="274320"/>
+          </a:xfrm>
+          <a:prstGeom prst="rect">
+            <a:avLst/>
+          </a:prstGeom>
+          <a:noFill/>
+        </p:spPr>
+        <p:txBody>
+          <a:bodyPr wrap="none">
+            <a:spAutoFit/>
+          </a:bodyPr>
+          <a:lstStyle/>
+          <a:p>
+            <a:r>
+              <a:rPr sz="1200" b="1">
+                <a:solidFill>
+                  <a:srgbClr val="1B3A5C"/>
+                </a:solidFill>
+              </a:rPr>
+              <a:t>DUNCAN &amp; CO.</a:t>
+            </a:r>
+          </a:p>
+        </p:txBody>
+      </p:sp>
+      <p:sp>
+        <p:nvSpPr>
+          <p:cNvPr id="3" name="TextBox 2"/>
+          <p:cNvSpPr txBox="1"/>
+          <p:nvPr/>
+        </p:nvSpPr>
+        <p:spPr>
+          <a:xfrm>
+            <a:off x="914400" y="365760"/>
+            <a:ext cx="7772400" cy="914400"/>
+          </a:xfrm>
+          <a:prstGeom prst="rect">
+            <a:avLst/>
+          </a:prstGeom>
+          <a:noFill/>
+        </p:spPr>
+        <p:txBody>
+          <a:bodyPr wrap="square">
+            <a:spAutoFit/>
+          </a:bodyPr>
+          <a:lstStyle/>
+          <a:p>
+            <a:r>
+              <a:rPr sz="2500" b="1">
+                <a:solidFill>
+                  <a:srgbClr val="1B3A5C"/>
+                </a:solidFill>
+              </a:rPr>
+              <a:t>Open Questions &amp; Follow-Ups from Site Visit</a:t>
+            </a:r>
+          </a:p>
+        </p:txBody>
+      </p:sp>
+      <p:sp>
+        <p:nvSpPr>
+          <p:cNvPr id="4" name="Rectangle 3"/>
+          <p:cNvSpPr/>
+          <p:nvPr/>
+        </p:nvSpPr>
+        <p:spPr>
+          <a:xfrm>
+            <a:off x="457200" y="914400"/>
+            <a:ext cx="7772400" cy="18288"/>
+          </a:xfrm>
+          <a:prstGeom prst="rect">
+            <a:avLst/>
+          </a:prstGeom>
+          <a:solidFill>
+            <a:srgbClr val="E8792C"/>
+          </a:solidFill>
+          <a:ln>
+            <a:noFill/>
+          </a:ln>
+        </p:spPr>
+        <p:style>
+          <a:lnRef idx="1">
+            <a:schemeClr val="accent1"/>
+          </a:lnRef>
+          <a:fillRef idx="3">
+            <a:schemeClr val="accent1"/>
+          </a:fillRef>
+          <a:effectRef idx="2">
+            <a:schemeClr val="accent1"/>
+          </a:effectRef>
+          <a:fontRef idx="minor">
+            <a:schemeClr val="lt1"/>
+          </a:fontRef>
+        </p:style>
+        <p:txBody>
+          <a:bodyPr rtlCol="0" anchor="ctr"/>
+          <a:lstStyle/>
+          <a:p>
+            <a:pPr algn="ctr"/>
+          </a:p>
+        </p:txBody>
+      </p:sp>
+      <p:sp>
+        <p:nvSpPr>
+          <p:cNvPr id="5" name="Rectangle 4"/>
+          <p:cNvSpPr/>
+          <p:nvPr/>
+        </p:nvSpPr>
+        <p:spPr>
+          <a:xfrm>
+            <a:off x="457200" y="4846320"/>
+            <a:ext cx="7772400" cy="18288"/>
+          </a:xfrm>
+          <a:prstGeom prst="rect">
+            <a:avLst/>
+          </a:prstGeom>
+          <a:solidFill>
+            <a:srgbClr val="808080"/>
+          </a:solidFill>
+          <a:ln>
+            <a:noFill/>
+          </a:ln>
+        </p:spPr>
+        <p:style>
+          <a:lnRef idx="1">
+            <a:schemeClr val="accent1"/>
+          </a:lnRef>
+          <a:fillRef idx="3">
+            <a:schemeClr val="accent1"/>
+          </a:fillRef>
+          <a:effectRef idx="2">
+            <a:schemeClr val="accent1"/>
+          </a:effectRef>
+          <a:fontRef idx="minor">
+            <a:schemeClr val="lt1"/>
+          </a:fontRef>
+        </p:style>
+        <p:txBody>
+          <a:bodyPr rtlCol="0" anchor="ctr"/>
+          <a:lstStyle/>
+          <a:p>
+            <a:pPr algn="ctr"/>
+          </a:p>
+        </p:txBody>
+      </p:sp>
+      <p:sp>
+        <p:nvSpPr>
+          <p:cNvPr id="6" name="TextBox 5"/>
+          <p:cNvSpPr txBox="1"/>
+          <p:nvPr/>
+        </p:nvSpPr>
+        <p:spPr>
+          <a:xfrm>
+            <a:off x="457200" y="4663440"/>
+            <a:ext cx="3657600" cy="274320"/>
+          </a:xfrm>
+          <a:prstGeom prst="rect">
+            <a:avLst/>
+          </a:prstGeom>
+          <a:noFill/>
+        </p:spPr>
+        <p:txBody>
+          <a:bodyPr wrap="none">
+            <a:spAutoFit/>
+          </a:bodyPr>
+          <a:lstStyle/>
+          <a:p>
+            <a:r>
+              <a:rPr sz="900">
+                <a:solidFill>
+                  <a:srgbClr val="808080"/>
+                </a:solidFill>
+              </a:rPr>
+              <a:t>Duncan &amp; Co.</a:t>
+            </a:r>
+          </a:p>
+        </p:txBody>
+      </p:sp>
+      <p:sp>
+        <p:nvSpPr>
+          <p:cNvPr id="7" name="TextBox 6"/>
+          <p:cNvSpPr txBox="1"/>
+          <p:nvPr/>
+        </p:nvSpPr>
+        <p:spPr>
+          <a:xfrm>
+            <a:off x="7772400" y="4663440"/>
+            <a:ext cx="457200" cy="182880"/>
+          </a:xfrm>
+          <a:prstGeom prst="rect">
+            <a:avLst/>
+          </a:prstGeom>
+          <a:noFill/>
+        </p:spPr>
+        <p:txBody>
+          <a:bodyPr wrap="none">
+            <a:spAutoFit/>
+          </a:bodyPr>
+          <a:lstStyle/>
+          <a:p>
+            <a:pPr algn="r"/>
+            <a:r>
+              <a:rPr sz="900">
+                <a:solidFill>
+                  <a:srgbClr val="808080"/>
+                </a:solidFill>
+              </a:rPr>
+              <a:t>5</a:t>
             </a:r>
           </a:p>
         </p:txBody>

</xml_diff>

<commit_message>
Created mock notes to translate into deck and full deck buildout python file
</commit_message>
<xml_diff>
--- a/example/template_test.pptx
+++ b/example/template_test.pptx
@@ -3161,7 +3161,7 @@
                   <a:srgbClr val="1B3A5C"/>
                 </a:solidFill>
               </a:rPr>
-              <a:t>Q1'26 Report</a:t>
+              <a:t>Test Slide</a:t>
             </a:r>
           </a:p>
         </p:txBody>
@@ -3343,6 +3343,59 @@
           </a:prstGeom>
         </p:spPr>
       </p:pic>
+      <p:sp>
+        <p:nvSpPr>
+          <p:cNvPr id="9" name="TextBox 8"/>
+          <p:cNvSpPr txBox="1"/>
+          <p:nvPr/>
+        </p:nvSpPr>
+        <p:spPr>
+          <a:xfrm>
+            <a:off x="1371600" y="1828800"/>
+            <a:ext cx="7223760" cy="2560320"/>
+          </a:xfrm>
+          <a:prstGeom prst="rect">
+            <a:avLst/>
+          </a:prstGeom>
+          <a:noFill/>
+        </p:spPr>
+        <p:txBody>
+          <a:bodyPr wrap="square">
+            <a:spAutoFit/>
+          </a:bodyPr>
+          <a:lstStyle/>
+          <a:p>
+            <a:pPr>
+              <a:spcAft>
+                <a:spcPts val="900"/>
+              </a:spcAft>
+              <a:defRPr sz="1200">
+                <a:solidFill>
+                  <a:srgbClr val="2B2B2B"/>
+                </a:solidFill>
+              </a:defRPr>
+            </a:pPr>
+            <a:r>
+              <a:t>• First point here</a:t>
+            </a:r>
+          </a:p>
+          <a:p>
+            <a:pPr>
+              <a:spcAft>
+                <a:spcPts val="900"/>
+              </a:spcAft>
+              <a:defRPr sz="1200">
+                <a:solidFill>
+                  <a:srgbClr val="2B2B2B"/>
+                </a:solidFill>
+              </a:defRPr>
+            </a:pPr>
+            <a:r>
+              <a:t>• Second point here</a:t>
+            </a:r>
+          </a:p>
+        </p:txBody>
+      </p:sp>
     </p:spTree>
   </p:cSld>
   <p:clrMapOvr>

</xml_diff>